<commit_message>
feat(.agents,scripts): add diagram generation planning and widget review documentation
</commit_message>
<xml_diff>
--- a/OUTPUT/Urbani_AWS_Architecture_v3.pptx
+++ b/OUTPUT/Urbani_AWS_Architecture_v3.pptx
@@ -1356,7 +1356,7 @@
                   <a:srgbClr val="667085"/>
                 </a:solidFill>
               </a:rPr>
-              <a:t>Custom Web Dashboard  ·  AI Log Chatbot  ·  Live Logs  ·  AWS CDK  —  v3.0</a:t>
+              <a:t>Custom Web Dashboard  ·  AI Log Chatbot  ·  Live Logs  ·  AWS CDK  —  v3.0 Proposal</a:t>
             </a:r>
             <a:endParaRPr lang="en-US" sz="1500" dirty="0"/>
           </a:p>
@@ -1447,7 +1447,7 @@
                 <a:ea typeface="Calibri" pitchFamily="34" charset="-122"/>
                 <a:cs typeface="Calibri" pitchFamily="34" charset="-120"/>
               </a:rPr>
-              <a:t>What We Deliver</a:t>
+              <a:t>What We Propose</a:t>
             </a:r>
             <a:endParaRPr lang="en-US" sz="2600" dirty="0"/>
           </a:p>
@@ -1523,7 +1523,7 @@
                   <a:srgbClr val="172033"/>
                 </a:solidFill>
               </a:rPr>
-              <a:t>Live Urbani log integration via API Gateway (LIVE provenance labels)</a:t>
+              <a:t>Urbani log integration via API Gateway with clear data-provenance labels</a:t>
             </a:r>
             <a:endParaRPr lang="en-US" sz="1800" dirty="0"/>
           </a:p>
@@ -1577,7 +1577,7 @@
                   <a:srgbClr val="172033"/>
                 </a:solidFill>
               </a:rPr>
-              <a:t>Full infrastructure as AWS CDK (TypeScript) — synth-validated</a:t>
+              <a:t>Full infrastructure as AWS CDK (TypeScript)</a:t>
             </a:r>
             <a:endParaRPr lang="en-US" sz="1800" dirty="0"/>
           </a:p>
@@ -2772,7 +2772,7 @@
                 <a:ea typeface="Calibri" pitchFamily="34" charset="-122"/>
                 <a:cs typeface="Calibri" pitchFamily="34" charset="-120"/>
               </a:rPr>
-              <a:t>Delivery Status &amp; Next Steps</a:t>
+              <a:t>Delivery Plan &amp; Prerequisites</a:t>
             </a:r>
             <a:endParaRPr lang="en-US" sz="2600" dirty="0"/>
           </a:p>
@@ -2808,7 +2808,7 @@
                   <a:srgbClr val="D1990A"/>
                 </a:solidFill>
               </a:rPr>
-              <a:t>Delivered</a:t>
+              <a:t>Proposed Phases</a:t>
             </a:r>
             <a:endParaRPr lang="en-US" sz="1800" dirty="0"/>
           </a:p>
@@ -2884,7 +2884,7 @@
                   <a:srgbClr val="172033"/>
                 </a:solidFill>
               </a:rPr>
-              <a:t>Live logs API (LIVE)</a:t>
+              <a:t>Logs API integration</a:t>
             </a:r>
             <a:endParaRPr lang="en-US" sz="1500" dirty="0"/>
           </a:p>
@@ -2920,7 +2920,25 @@
                   <a:srgbClr val="172033"/>
                 </a:solidFill>
               </a:rPr>
-              <a:t>AWS CDK stack (synth-validated)</a:t>
+              <a:t>AWS CDK stack</a:t>
+            </a:r>
+            <a:endParaRPr lang="en-US" sz="1500" dirty="0"/>
+          </a:p>
+          <a:p>
+            <a:pPr marL="342900" indent="-342900">
+              <a:spcAft>
+                <a:spcPts val="800"/>
+              </a:spcAft>
+              <a:buSzPct val="100000"/>
+              <a:buChar char="•"/>
+            </a:pPr>
+            <a:r>
+              <a:rPr lang="en-US" sz="1500" dirty="0">
+                <a:solidFill>
+                  <a:srgbClr val="172033"/>
+                </a:solidFill>
+              </a:rPr>
+              <a:t>Bedrock enablement + full deploy</a:t>
             </a:r>
             <a:endParaRPr lang="en-US" sz="1500" dirty="0"/>
           </a:p>
@@ -2956,7 +2974,7 @@
                   <a:srgbClr val="172033"/>
                 </a:solidFill>
               </a:rPr>
-              <a:t>Awaiting Client / AWS</a:t>
+              <a:t>Prerequisites from Client / AWS</a:t>
             </a:r>
             <a:endParaRPr lang="en-US" sz="1800" dirty="0"/>
           </a:p>
@@ -3068,7 +3086,7 @@
                   <a:srgbClr val="172033"/>
                 </a:solidFill>
               </a:rPr>
-              <a:t>Rotate shared logs API key</a:t>
+              <a:t>Secure handling of logs API key</a:t>
             </a:r>
             <a:endParaRPr lang="en-US" sz="1500" dirty="0"/>
           </a:p>

</xml_diff>